<commit_message>
feat(phase4-5): Member C remaining tasks (T4.6 UI Explainability & T5.6 15-Slide Pitch Deck)
</commit_message>
<xml_diff>
--- a/docs/HQML_Presentation_Deck.pptx
+++ b/docs/HQML_Presentation_Deck.pptx
@@ -4228,7 +4228,7 @@
                         <a:defRPr sz="1000"/>
                       </a:pPr>
                       <a:r>
-                        <a:t>QSVC vs Linear SVM</a:t>
+                        <a:t>VQC vs Random Forest</a:t>
                       </a:r>
                     </a:p>
                   </a:txBody>
@@ -4247,7 +4247,7 @@
                         <a:defRPr sz="1000"/>
                       </a:pPr>
                       <a:r>
-                        <a:t>+0.0142</a:t>
+                        <a:t>+0.0472</a:t>
                       </a:r>
                     </a:p>
                   </a:txBody>
@@ -4266,7 +4266,7 @@
                         <a:defRPr sz="1000"/>
                       </a:pPr>
                       <a:r>
-                        <a:t>1.10</a:t>
+                        <a:t>1.28</a:t>
                       </a:r>
                     </a:p>
                   </a:txBody>
@@ -4285,7 +4285,7 @@
                         <a:defRPr sz="1000"/>
                       </a:pPr>
                       <a:r>
-                        <a:t>p = 0.0353</a:t>
+                        <a:t>p = 0.0231</a:t>
                       </a:r>
                     </a:p>
                   </a:txBody>
@@ -4329,7 +4329,7 @@
                         <a:defRPr sz="1000"/>
                       </a:pPr>
                       <a:r>
-                        <a:t>QSVC vs RBF SVM</a:t>
+                        <a:t>VQC vs Linear SVM</a:t>
                       </a:r>
                     </a:p>
                   </a:txBody>
@@ -4430,7 +4430,7 @@
                         <a:defRPr sz="1000"/>
                       </a:pPr>
                       <a:r>
-                        <a:t>VQC vs Linear SVM</a:t>
+                        <a:t>VQC vs RBF SVM</a:t>
                       </a:r>
                     </a:p>
                   </a:txBody>
@@ -4531,7 +4531,7 @@
                         <a:defRPr sz="1000"/>
                       </a:pPr>
                       <a:r>
-                        <a:t>VQC vs RBF SVM</a:t>
+                        <a:t>QSVC vs Random Forest</a:t>
                       </a:r>
                     </a:p>
                   </a:txBody>
@@ -4550,7 +4550,7 @@
                         <a:defRPr sz="1000"/>
                       </a:pPr>
                       <a:r>
-                        <a:t>+0.0188</a:t>
+                        <a:t>+0.0379</a:t>
                       </a:r>
                     </a:p>
                   </a:txBody>
@@ -4632,7 +4632,7 @@
                         <a:defRPr sz="1000"/>
                       </a:pPr>
                       <a:r>
-                        <a:t>QSVC vs Random Forest</a:t>
+                        <a:t>VQC vs XGBoost</a:t>
                       </a:r>
                     </a:p>
                   </a:txBody>
@@ -4651,7 +4651,7 @@
                         <a:defRPr sz="1000"/>
                       </a:pPr>
                       <a:r>
-                        <a:t>+0.0283</a:t>
+                        <a:t>+0.0332</a:t>
                       </a:r>
                     </a:p>
                   </a:txBody>
@@ -4670,7 +4670,7 @@
                         <a:defRPr sz="1000"/>
                       </a:pPr>
                       <a:r>
-                        <a:t>0.92</a:t>
+                        <a:t>0.77</a:t>
                       </a:r>
                     </a:p>
                   </a:txBody>
@@ -4689,7 +4689,7 @@
                         <a:defRPr sz="1000"/>
                       </a:pPr>
                       <a:r>
-                        <a:t>p = 0.0547</a:t>
+                        <a:t>p = 0.0795</a:t>
                       </a:r>
                     </a:p>
                   </a:txBody>
@@ -4708,7 +4708,7 @@
                         <a:defRPr sz="1000"/>
                       </a:pPr>
                       <a:r>
-                        <a:t>Marginal Parity</a:t>
+                        <a:t>Comparable</a:t>
                       </a:r>
                     </a:p>
                   </a:txBody>
@@ -10528,8 +10528,8 @@
           <p:nvPr/>
         </p:nvGraphicFramePr>
         <p:xfrm>
-          <a:off x="731520" y="1463040"/>
-          <a:ext cx="10698480" cy="4114800"/>
+          <a:off x="731520" y="1371600"/>
+          <a:ext cx="10698480" cy="4297680"/>
         </p:xfrm>
         <a:graphic>
           <a:graphicData uri="http://schemas.openxmlformats.org/drawingml/2006/table">
@@ -10546,7 +10546,7 @@
                 <a:gridCol w="1371600"/>
                 <a:gridCol w="1371600"/>
               </a:tblGrid>
-              <a:tr h="514350">
+              <a:tr h="477520">
                 <a:tc>
                   <a:txBody>
                     <a:bodyPr/>
@@ -10709,7 +10709,722 @@
                   </a:tcPr>
                 </a:tc>
               </a:tr>
-              <a:tr h="514350">
+              <a:tr h="477520">
+                <a:tc>
+                  <a:txBody>
+                    <a:bodyPr/>
+                    <a:lstStyle/>
+                    <a:p>
+                      <a:pPr>
+                        <a:defRPr sz="1000" b="1">
+                          <a:solidFill>
+                            <a:srgbClr val="0F2027"/>
+                          </a:solidFill>
+                        </a:defRPr>
+                      </a:pPr>
+                      <a:r>
+                        <a:t>Linear SVM (Classical)</a:t>
+                      </a:r>
+                    </a:p>
+                  </a:txBody>
+                  <a:tcPr>
+                    <a:solidFill>
+                      <a:srgbClr val="FFFFFF"/>
+                    </a:solidFill>
+                  </a:tcPr>
+                </a:tc>
+                <a:tc>
+                  <a:txBody>
+                    <a:bodyPr/>
+                    <a:lstStyle/>
+                    <a:p>
+                      <a:pPr algn="ctr">
+                        <a:defRPr sz="1000"/>
+                      </a:pPr>
+                      <a:r>
+                        <a:t>Classical</a:t>
+                      </a:r>
+                    </a:p>
+                  </a:txBody>
+                  <a:tcPr>
+                    <a:solidFill>
+                      <a:srgbClr val="FFFFFF"/>
+                    </a:solidFill>
+                  </a:tcPr>
+                </a:tc>
+                <a:tc>
+                  <a:txBody>
+                    <a:bodyPr/>
+                    <a:lstStyle/>
+                    <a:p>
+                      <a:pPr algn="ctr">
+                        <a:defRPr sz="1000"/>
+                      </a:pPr>
+                      <a:r>
+                        <a:t>0.9596 ± 0.0099</a:t>
+                      </a:r>
+                    </a:p>
+                  </a:txBody>
+                  <a:tcPr>
+                    <a:solidFill>
+                      <a:srgbClr val="FFFFFF"/>
+                    </a:solidFill>
+                  </a:tcPr>
+                </a:tc>
+                <a:tc>
+                  <a:txBody>
+                    <a:bodyPr/>
+                    <a:lstStyle/>
+                    <a:p>
+                      <a:pPr algn="ctr">
+                        <a:defRPr sz="1000" b="1">
+                          <a:solidFill>
+                            <a:srgbClr val="0F2027"/>
+                          </a:solidFill>
+                        </a:defRPr>
+                      </a:pPr>
+                      <a:r>
+                        <a:t>0.9435 ± 0.0486</a:t>
+                      </a:r>
+                    </a:p>
+                  </a:txBody>
+                  <a:tcPr>
+                    <a:solidFill>
+                      <a:srgbClr val="FFFFFF"/>
+                    </a:solidFill>
+                  </a:tcPr>
+                </a:tc>
+                <a:tc>
+                  <a:txBody>
+                    <a:bodyPr/>
+                    <a:lstStyle/>
+                    <a:p>
+                      <a:pPr algn="ctr">
+                        <a:defRPr sz="1000"/>
+                      </a:pPr>
+                      <a:r>
+                        <a:t>0.9692 ± 0.0302</a:t>
+                      </a:r>
+                    </a:p>
+                  </a:txBody>
+                  <a:tcPr>
+                    <a:solidFill>
+                      <a:srgbClr val="FFFFFF"/>
+                    </a:solidFill>
+                  </a:tcPr>
+                </a:tc>
+                <a:tc>
+                  <a:txBody>
+                    <a:bodyPr/>
+                    <a:lstStyle/>
+                    <a:p>
+                      <a:pPr algn="ctr">
+                        <a:defRPr sz="1000"/>
+                      </a:pPr>
+                      <a:r>
+                        <a:t>0.9457 ± 0.0133</a:t>
+                      </a:r>
+                    </a:p>
+                  </a:txBody>
+                  <a:tcPr>
+                    <a:solidFill>
+                      <a:srgbClr val="FFFFFF"/>
+                    </a:solidFill>
+                  </a:tcPr>
+                </a:tc>
+                <a:tc>
+                  <a:txBody>
+                    <a:bodyPr/>
+                    <a:lstStyle/>
+                    <a:p>
+                      <a:pPr algn="ctr">
+                        <a:defRPr sz="1000"/>
+                      </a:pPr>
+                      <a:r>
+                        <a:t>0.9935 ± 0.0053</a:t>
+                      </a:r>
+                    </a:p>
+                  </a:txBody>
+                  <a:tcPr>
+                    <a:solidFill>
+                      <a:srgbClr val="FFFFFF"/>
+                    </a:solidFill>
+                  </a:tcPr>
+                </a:tc>
+              </a:tr>
+              <a:tr h="477520">
+                <a:tc>
+                  <a:txBody>
+                    <a:bodyPr/>
+                    <a:lstStyle/>
+                    <a:p>
+                      <a:pPr>
+                        <a:defRPr sz="1000" b="1">
+                          <a:solidFill>
+                            <a:srgbClr val="0F2027"/>
+                          </a:solidFill>
+                        </a:defRPr>
+                      </a:pPr>
+                      <a:r>
+                        <a:t>RBF SVM (Classical)</a:t>
+                      </a:r>
+                    </a:p>
+                  </a:txBody>
+                  <a:tcPr>
+                    <a:solidFill>
+                      <a:srgbClr val="F5F7FA"/>
+                    </a:solidFill>
+                  </a:tcPr>
+                </a:tc>
+                <a:tc>
+                  <a:txBody>
+                    <a:bodyPr/>
+                    <a:lstStyle/>
+                    <a:p>
+                      <a:pPr algn="ctr">
+                        <a:defRPr sz="1000"/>
+                      </a:pPr>
+                      <a:r>
+                        <a:t>Classical</a:t>
+                      </a:r>
+                    </a:p>
+                  </a:txBody>
+                  <a:tcPr>
+                    <a:solidFill>
+                      <a:srgbClr val="F5F7FA"/>
+                    </a:solidFill>
+                  </a:tcPr>
+                </a:tc>
+                <a:tc>
+                  <a:txBody>
+                    <a:bodyPr/>
+                    <a:lstStyle/>
+                    <a:p>
+                      <a:pPr algn="ctr">
+                        <a:defRPr sz="1000"/>
+                      </a:pPr>
+                      <a:r>
+                        <a:t>0.9649 ± 0.0205</a:t>
+                      </a:r>
+                    </a:p>
+                  </a:txBody>
+                  <a:tcPr>
+                    <a:solidFill>
+                      <a:srgbClr val="F5F7FA"/>
+                    </a:solidFill>
+                  </a:tcPr>
+                </a:tc>
+                <a:tc>
+                  <a:txBody>
+                    <a:bodyPr/>
+                    <a:lstStyle/>
+                    <a:p>
+                      <a:pPr algn="ctr">
+                        <a:defRPr sz="1000" b="1">
+                          <a:solidFill>
+                            <a:srgbClr val="0F2027"/>
+                          </a:solidFill>
+                        </a:defRPr>
+                      </a:pPr>
+                      <a:r>
+                        <a:t>0.9389 ± 0.0563</a:t>
+                      </a:r>
+                    </a:p>
+                  </a:txBody>
+                  <a:tcPr>
+                    <a:solidFill>
+                      <a:srgbClr val="F5F7FA"/>
+                    </a:solidFill>
+                  </a:tcPr>
+                </a:tc>
+                <a:tc>
+                  <a:txBody>
+                    <a:bodyPr/>
+                    <a:lstStyle/>
+                    <a:p>
+                      <a:pPr algn="ctr">
+                        <a:defRPr sz="1000"/>
+                      </a:pPr>
+                      <a:r>
+                        <a:t>0.9804 ± 0.0187</a:t>
+                      </a:r>
+                    </a:p>
+                  </a:txBody>
+                  <a:tcPr>
+                    <a:solidFill>
+                      <a:srgbClr val="F5F7FA"/>
+                    </a:solidFill>
+                  </a:tcPr>
+                </a:tc>
+                <a:tc>
+                  <a:txBody>
+                    <a:bodyPr/>
+                    <a:lstStyle/>
+                    <a:p>
+                      <a:pPr algn="ctr">
+                        <a:defRPr sz="1000"/>
+                      </a:pPr>
+                      <a:r>
+                        <a:t>0.9518 ± 0.0291</a:t>
+                      </a:r>
+                    </a:p>
+                  </a:txBody>
+                  <a:tcPr>
+                    <a:solidFill>
+                      <a:srgbClr val="F5F7FA"/>
+                    </a:solidFill>
+                  </a:tcPr>
+                </a:tc>
+                <a:tc>
+                  <a:txBody>
+                    <a:bodyPr/>
+                    <a:lstStyle/>
+                    <a:p>
+                      <a:pPr algn="ctr">
+                        <a:defRPr sz="1000"/>
+                      </a:pPr>
+                      <a:r>
+                        <a:t>0.9953 ± 0.0052</a:t>
+                      </a:r>
+                    </a:p>
+                  </a:txBody>
+                  <a:tcPr>
+                    <a:solidFill>
+                      <a:srgbClr val="F5F7FA"/>
+                    </a:solidFill>
+                  </a:tcPr>
+                </a:tc>
+              </a:tr>
+              <a:tr h="477520">
+                <a:tc>
+                  <a:txBody>
+                    <a:bodyPr/>
+                    <a:lstStyle/>
+                    <a:p>
+                      <a:pPr>
+                        <a:defRPr sz="1000" b="1">
+                          <a:solidFill>
+                            <a:srgbClr val="0F2027"/>
+                          </a:solidFill>
+                        </a:defRPr>
+                      </a:pPr>
+                      <a:r>
+                        <a:t>Random Forest (Classical)</a:t>
+                      </a:r>
+                    </a:p>
+                  </a:txBody>
+                  <a:tcPr>
+                    <a:solidFill>
+                      <a:srgbClr val="FFFFFF"/>
+                    </a:solidFill>
+                  </a:tcPr>
+                </a:tc>
+                <a:tc>
+                  <a:txBody>
+                    <a:bodyPr/>
+                    <a:lstStyle/>
+                    <a:p>
+                      <a:pPr algn="ctr">
+                        <a:defRPr sz="1000"/>
+                      </a:pPr>
+                      <a:r>
+                        <a:t>Classical</a:t>
+                      </a:r>
+                    </a:p>
+                  </a:txBody>
+                  <a:tcPr>
+                    <a:solidFill>
+                      <a:srgbClr val="FFFFFF"/>
+                    </a:solidFill>
+                  </a:tcPr>
+                </a:tc>
+                <a:tc>
+                  <a:txBody>
+                    <a:bodyPr/>
+                    <a:lstStyle/>
+                    <a:p>
+                      <a:pPr algn="ctr">
+                        <a:defRPr sz="1000"/>
+                      </a:pPr>
+                      <a:r>
+                        <a:t>0.9456 ± 0.0280</a:t>
+                      </a:r>
+                    </a:p>
+                  </a:txBody>
+                  <a:tcPr>
+                    <a:solidFill>
+                      <a:srgbClr val="FFFFFF"/>
+                    </a:solidFill>
+                  </a:tcPr>
+                </a:tc>
+                <a:tc>
+                  <a:txBody>
+                    <a:bodyPr/>
+                    <a:lstStyle/>
+                    <a:p>
+                      <a:pPr algn="ctr">
+                        <a:defRPr sz="1000" b="1">
+                          <a:solidFill>
+                            <a:srgbClr val="0F2027"/>
+                          </a:solidFill>
+                        </a:defRPr>
+                      </a:pPr>
+                      <a:r>
+                        <a:t>0.9105 ± 0.0708</a:t>
+                      </a:r>
+                    </a:p>
+                  </a:txBody>
+                  <a:tcPr>
+                    <a:solidFill>
+                      <a:srgbClr val="FFFFFF"/>
+                    </a:solidFill>
+                  </a:tcPr>
+                </a:tc>
+                <a:tc>
+                  <a:txBody>
+                    <a:bodyPr/>
+                    <a:lstStyle/>
+                    <a:p>
+                      <a:pPr algn="ctr">
+                        <a:defRPr sz="1000"/>
+                      </a:pPr>
+                      <a:r>
+                        <a:t>0.9665 ± 0.0445</a:t>
+                      </a:r>
+                    </a:p>
+                  </a:txBody>
+                  <a:tcPr>
+                    <a:solidFill>
+                      <a:srgbClr val="FFFFFF"/>
+                    </a:solidFill>
+                  </a:tcPr>
+                </a:tc>
+                <a:tc>
+                  <a:txBody>
+                    <a:bodyPr/>
+                    <a:lstStyle/>
+                    <a:p>
+                      <a:pPr algn="ctr">
+                        <a:defRPr sz="1000"/>
+                      </a:pPr>
+                      <a:r>
+                        <a:t>0.9254 ± 0.0377</a:t>
+                      </a:r>
+                    </a:p>
+                  </a:txBody>
+                  <a:tcPr>
+                    <a:solidFill>
+                      <a:srgbClr val="FFFFFF"/>
+                    </a:solidFill>
+                  </a:tcPr>
+                </a:tc>
+                <a:tc>
+                  <a:txBody>
+                    <a:bodyPr/>
+                    <a:lstStyle/>
+                    <a:p>
+                      <a:pPr algn="ctr">
+                        <a:defRPr sz="1000"/>
+                      </a:pPr>
+                      <a:r>
+                        <a:t>0.9862 ± 0.0109</a:t>
+                      </a:r>
+                    </a:p>
+                  </a:txBody>
+                  <a:tcPr>
+                    <a:solidFill>
+                      <a:srgbClr val="FFFFFF"/>
+                    </a:solidFill>
+                  </a:tcPr>
+                </a:tc>
+              </a:tr>
+              <a:tr h="477520">
+                <a:tc>
+                  <a:txBody>
+                    <a:bodyPr/>
+                    <a:lstStyle/>
+                    <a:p>
+                      <a:pPr>
+                        <a:defRPr sz="1000" b="1">
+                          <a:solidFill>
+                            <a:srgbClr val="0F2027"/>
+                          </a:solidFill>
+                        </a:defRPr>
+                      </a:pPr>
+                      <a:r>
+                        <a:t>XGBoost (Classical)</a:t>
+                      </a:r>
+                    </a:p>
+                  </a:txBody>
+                  <a:tcPr>
+                    <a:solidFill>
+                      <a:srgbClr val="F5F7FA"/>
+                    </a:solidFill>
+                  </a:tcPr>
+                </a:tc>
+                <a:tc>
+                  <a:txBody>
+                    <a:bodyPr/>
+                    <a:lstStyle/>
+                    <a:p>
+                      <a:pPr algn="ctr">
+                        <a:defRPr sz="1000"/>
+                      </a:pPr>
+                      <a:r>
+                        <a:t>Classical</a:t>
+                      </a:r>
+                    </a:p>
+                  </a:txBody>
+                  <a:tcPr>
+                    <a:solidFill>
+                      <a:srgbClr val="F5F7FA"/>
+                    </a:solidFill>
+                  </a:tcPr>
+                </a:tc>
+                <a:tc>
+                  <a:txBody>
+                    <a:bodyPr/>
+                    <a:lstStyle/>
+                    <a:p>
+                      <a:pPr algn="ctr">
+                        <a:defRPr sz="1000"/>
+                      </a:pPr>
+                      <a:r>
+                        <a:t>0.9561 ± 0.0223</a:t>
+                      </a:r>
+                    </a:p>
+                  </a:txBody>
+                  <a:tcPr>
+                    <a:solidFill>
+                      <a:srgbClr val="F5F7FA"/>
+                    </a:solidFill>
+                  </a:tcPr>
+                </a:tc>
+                <a:tc>
+                  <a:txBody>
+                    <a:bodyPr/>
+                    <a:lstStyle/>
+                    <a:p>
+                      <a:pPr algn="ctr">
+                        <a:defRPr sz="1000" b="1">
+                          <a:solidFill>
+                            <a:srgbClr val="0F2027"/>
+                          </a:solidFill>
+                        </a:defRPr>
+                      </a:pPr>
+                      <a:r>
+                        <a:t>0.9245 ± 0.0734</a:t>
+                      </a:r>
+                    </a:p>
+                  </a:txBody>
+                  <a:tcPr>
+                    <a:solidFill>
+                      <a:srgbClr val="F5F7FA"/>
+                    </a:solidFill>
+                  </a:tcPr>
+                </a:tc>
+                <a:tc>
+                  <a:txBody>
+                    <a:bodyPr/>
+                    <a:lstStyle/>
+                    <a:p>
+                      <a:pPr algn="ctr">
+                        <a:defRPr sz="1000"/>
+                      </a:pPr>
+                      <a:r>
+                        <a:t>0.9749 ± 0.0346</a:t>
+                      </a:r>
+                    </a:p>
+                  </a:txBody>
+                  <a:tcPr>
+                    <a:solidFill>
+                      <a:srgbClr val="F5F7FA"/>
+                    </a:solidFill>
+                  </a:tcPr>
+                </a:tc>
+                <a:tc>
+                  <a:txBody>
+                    <a:bodyPr/>
+                    <a:lstStyle/>
+                    <a:p>
+                      <a:pPr algn="ctr">
+                        <a:defRPr sz="1000"/>
+                      </a:pPr>
+                      <a:r>
+                        <a:t>0.9393 ± 0.0317</a:t>
+                      </a:r>
+                    </a:p>
+                  </a:txBody>
+                  <a:tcPr>
+                    <a:solidFill>
+                      <a:srgbClr val="F5F7FA"/>
+                    </a:solidFill>
+                  </a:tcPr>
+                </a:tc>
+                <a:tc>
+                  <a:txBody>
+                    <a:bodyPr/>
+                    <a:lstStyle/>
+                    <a:p>
+                      <a:pPr algn="ctr">
+                        <a:defRPr sz="1000"/>
+                      </a:pPr>
+                      <a:r>
+                        <a:t>0.9901 ± 0.0101</a:t>
+                      </a:r>
+                    </a:p>
+                  </a:txBody>
+                  <a:tcPr>
+                    <a:solidFill>
+                      <a:srgbClr val="F5F7FA"/>
+                    </a:solidFill>
+                  </a:tcPr>
+                </a:tc>
+              </a:tr>
+              <a:tr h="477520">
+                <a:tc>
+                  <a:txBody>
+                    <a:bodyPr/>
+                    <a:lstStyle/>
+                    <a:p>
+                      <a:pPr>
+                        <a:defRPr sz="1000" b="1">
+                          <a:solidFill>
+                            <a:srgbClr val="0F2027"/>
+                          </a:solidFill>
+                        </a:defRPr>
+                      </a:pPr>
+                      <a:r>
+                        <a:t>MLP (Classical)</a:t>
+                      </a:r>
+                    </a:p>
+                  </a:txBody>
+                  <a:tcPr>
+                    <a:solidFill>
+                      <a:srgbClr val="FFFFFF"/>
+                    </a:solidFill>
+                  </a:tcPr>
+                </a:tc>
+                <a:tc>
+                  <a:txBody>
+                    <a:bodyPr/>
+                    <a:lstStyle/>
+                    <a:p>
+                      <a:pPr algn="ctr">
+                        <a:defRPr sz="1000"/>
+                      </a:pPr>
+                      <a:r>
+                        <a:t>Classical</a:t>
+                      </a:r>
+                    </a:p>
+                  </a:txBody>
+                  <a:tcPr>
+                    <a:solidFill>
+                      <a:srgbClr val="FFFFFF"/>
+                    </a:solidFill>
+                  </a:tcPr>
+                </a:tc>
+                <a:tc>
+                  <a:txBody>
+                    <a:bodyPr/>
+                    <a:lstStyle/>
+                    <a:p>
+                      <a:pPr algn="ctr">
+                        <a:defRPr sz="1000"/>
+                      </a:pPr>
+                      <a:r>
+                        <a:t>0.9754 ± 0.0073</a:t>
+                      </a:r>
+                    </a:p>
+                  </a:txBody>
+                  <a:tcPr>
+                    <a:solidFill>
+                      <a:srgbClr val="FFFFFF"/>
+                    </a:solidFill>
+                  </a:tcPr>
+                </a:tc>
+                <a:tc>
+                  <a:txBody>
+                    <a:bodyPr/>
+                    <a:lstStyle/>
+                    <a:p>
+                      <a:pPr algn="ctr">
+                        <a:defRPr sz="1000" b="1">
+                          <a:solidFill>
+                            <a:srgbClr val="0F2027"/>
+                          </a:solidFill>
+                        </a:defRPr>
+                      </a:pPr>
+                      <a:r>
+                        <a:t>0.9622 ± 0.0271</a:t>
+                      </a:r>
+                    </a:p>
+                  </a:txBody>
+                  <a:tcPr>
+                    <a:solidFill>
+                      <a:srgbClr val="FFFFFF"/>
+                    </a:solidFill>
+                  </a:tcPr>
+                </a:tc>
+                <a:tc>
+                  <a:txBody>
+                    <a:bodyPr/>
+                    <a:lstStyle/>
+                    <a:p>
+                      <a:pPr algn="ctr">
+                        <a:defRPr sz="1000"/>
+                      </a:pPr>
+                      <a:r>
+                        <a:t>0.9832 ± 0.0230</a:t>
+                      </a:r>
+                    </a:p>
+                  </a:txBody>
+                  <a:tcPr>
+                    <a:solidFill>
+                      <a:srgbClr val="FFFFFF"/>
+                    </a:solidFill>
+                  </a:tcPr>
+                </a:tc>
+                <a:tc>
+                  <a:txBody>
+                    <a:bodyPr/>
+                    <a:lstStyle/>
+                    <a:p>
+                      <a:pPr algn="ctr">
+                        <a:defRPr sz="1000"/>
+                      </a:pPr>
+                      <a:r>
+                        <a:t>0.9670 ± 0.0091</a:t>
+                      </a:r>
+                    </a:p>
+                  </a:txBody>
+                  <a:tcPr>
+                    <a:solidFill>
+                      <a:srgbClr val="FFFFFF"/>
+                    </a:solidFill>
+                  </a:tcPr>
+                </a:tc>
+                <a:tc>
+                  <a:txBody>
+                    <a:bodyPr/>
+                    <a:lstStyle/>
+                    <a:p>
+                      <a:pPr algn="ctr">
+                        <a:defRPr sz="1000"/>
+                      </a:pPr>
+                      <a:r>
+                        <a:t>0.9928 ± 0.0066</a:t>
+                      </a:r>
+                    </a:p>
+                  </a:txBody>
+                  <a:tcPr>
+                    <a:solidFill>
+                      <a:srgbClr val="FFFFFF"/>
+                    </a:solidFill>
+                  </a:tcPr>
+                </a:tc>
+              </a:tr>
+              <a:tr h="477520">
                 <a:tc>
                   <a:txBody>
                     <a:bodyPr/>
@@ -10724,6 +11439,149 @@
                       </a:pPr>
                       <a:r>
                         <a:t>QSVC (Quantum)</a:t>
+                      </a:r>
+                    </a:p>
+                  </a:txBody>
+                  <a:tcPr>
+                    <a:solidFill>
+                      <a:srgbClr val="EDE7F6"/>
+                    </a:solidFill>
+                  </a:tcPr>
+                </a:tc>
+                <a:tc>
+                  <a:txBody>
+                    <a:bodyPr/>
+                    <a:lstStyle/>
+                    <a:p>
+                      <a:pPr algn="ctr">
+                        <a:defRPr sz="1000"/>
+                      </a:pPr>
+                      <a:r>
+                        <a:t>Quantum</a:t>
+                      </a:r>
+                    </a:p>
+                  </a:txBody>
+                  <a:tcPr>
+                    <a:solidFill>
+                      <a:srgbClr val="EDE7F6"/>
+                    </a:solidFill>
+                  </a:tcPr>
+                </a:tc>
+                <a:tc>
+                  <a:txBody>
+                    <a:bodyPr/>
+                    <a:lstStyle/>
+                    <a:p>
+                      <a:pPr algn="ctr">
+                        <a:defRPr sz="1000"/>
+                      </a:pPr>
+                      <a:r>
+                        <a:t>0.9649 ± 0.0175</a:t>
+                      </a:r>
+                    </a:p>
+                  </a:txBody>
+                  <a:tcPr>
+                    <a:solidFill>
+                      <a:srgbClr val="EDE7F6"/>
+                    </a:solidFill>
+                  </a:tcPr>
+                </a:tc>
+                <a:tc>
+                  <a:txBody>
+                    <a:bodyPr/>
+                    <a:lstStyle/>
+                    <a:p>
+                      <a:pPr algn="ctr">
+                        <a:defRPr sz="1000" b="1">
+                          <a:solidFill>
+                            <a:srgbClr val="2E7D32"/>
+                          </a:solidFill>
+                        </a:defRPr>
+                      </a:pPr>
+                      <a:r>
+                        <a:t>0.9484 ± 0.0448</a:t>
+                      </a:r>
+                    </a:p>
+                  </a:txBody>
+                  <a:tcPr>
+                    <a:solidFill>
+                      <a:srgbClr val="EDE7F6"/>
+                    </a:solidFill>
+                  </a:tcPr>
+                </a:tc>
+                <a:tc>
+                  <a:txBody>
+                    <a:bodyPr/>
+                    <a:lstStyle/>
+                    <a:p>
+                      <a:pPr algn="ctr">
+                        <a:defRPr sz="1000"/>
+                      </a:pPr>
+                      <a:r>
+                        <a:t>0.9749 ± 0.0373</a:t>
+                      </a:r>
+                    </a:p>
+                  </a:txBody>
+                  <a:tcPr>
+                    <a:solidFill>
+                      <a:srgbClr val="EDE7F6"/>
+                    </a:solidFill>
+                  </a:tcPr>
+                </a:tc>
+                <a:tc>
+                  <a:txBody>
+                    <a:bodyPr/>
+                    <a:lstStyle/>
+                    <a:p>
+                      <a:pPr algn="ctr">
+                        <a:defRPr sz="1000"/>
+                      </a:pPr>
+                      <a:r>
+                        <a:t>0.9530 ± 0.0226</a:t>
+                      </a:r>
+                    </a:p>
+                  </a:txBody>
+                  <a:tcPr>
+                    <a:solidFill>
+                      <a:srgbClr val="EDE7F6"/>
+                    </a:solidFill>
+                  </a:tcPr>
+                </a:tc>
+                <a:tc>
+                  <a:txBody>
+                    <a:bodyPr/>
+                    <a:lstStyle/>
+                    <a:p>
+                      <a:pPr algn="ctr">
+                        <a:defRPr sz="1000"/>
+                      </a:pPr>
+                      <a:r>
+                        <a:t>0.9955 ± 0.0047</a:t>
+                      </a:r>
+                    </a:p>
+                  </a:txBody>
+                  <a:tcPr>
+                    <a:solidFill>
+                      <a:srgbClr val="EDE7F6"/>
+                    </a:solidFill>
+                  </a:tcPr>
+                </a:tc>
+              </a:tr>
+              <a:tr h="477520">
+                <a:tc>
+                  <a:txBody>
+                    <a:bodyPr/>
+                    <a:lstStyle/>
+                    <a:p>
+                      <a:pPr>
+                        <a:defRPr sz="1000" b="1">
+                          <a:solidFill>
+                            <a:srgbClr val="0F2027"/>
+                          </a:solidFill>
+                        </a:defRPr>
+                      </a:pPr>
+                      <a:r>
+                        <a:t>VQC (Quantum)</a:t>
                       </a:r>
                     </a:p>
                   </a:txBody>
@@ -10761,7 +11619,7 @@
                         <a:defRPr sz="1000"/>
                       </a:pPr>
                       <a:r>
-                        <a:t>0.9702 ± 0.013</a:t>
+                        <a:t>0.9666 ± 0.0073</a:t>
                       </a:r>
                     </a:p>
                   </a:txBody>
@@ -10784,7 +11642,7 @@
                         </a:defRPr>
                       </a:pPr>
                       <a:r>
-                        <a:t>0.9530 ± 0.047</a:t>
+                        <a:t>0.9577 ± 0.0385</a:t>
                       </a:r>
                     </a:p>
                   </a:txBody>
@@ -10803,7 +11661,7 @@
                         <a:defRPr sz="1000"/>
                       </a:pPr>
                       <a:r>
-                        <a:t>0.9804 ± 0.027</a:t>
+                        <a:t>0.9721 ± 0.0196</a:t>
                       </a:r>
                     </a:p>
                   </a:txBody>
@@ -10822,7 +11680,7 @@
                         <a:defRPr sz="1000"/>
                       </a:pPr>
                       <a:r>
-                        <a:t>0.9597 ± 0.018</a:t>
+                        <a:t>0.9551 ± 0.0106</a:t>
                       </a:r>
                     </a:p>
                   </a:txBody>
@@ -10841,7 +11699,7 @@
                         <a:defRPr sz="1000"/>
                       </a:pPr>
                       <a:r>
-                        <a:t>0.9955 ± 0.004</a:t>
+                        <a:t>0.9958 ± 0.0052</a:t>
                       </a:r>
                     </a:p>
                   </a:txBody>
@@ -10852,7 +11710,7 @@
                   </a:tcPr>
                 </a:tc>
               </a:tr>
-              <a:tr h="514350">
+              <a:tr h="477520">
                 <a:tc>
                   <a:txBody>
                     <a:bodyPr/>
@@ -10866,7 +11724,7 @@
                         </a:defRPr>
                       </a:pPr>
                       <a:r>
-                        <a:t>VQC (Quantum)</a:t>
+                        <a:t>HQNN (Quantum)</a:t>
                       </a:r>
                     </a:p>
                   </a:txBody>
@@ -10904,7 +11762,7 @@
                         <a:defRPr sz="1000"/>
                       </a:pPr>
                       <a:r>
-                        <a:t>0.9649 ± 0.006</a:t>
+                        <a:t>0.9684 ± 0.0133</a:t>
                       </a:r>
                     </a:p>
                   </a:txBody>
@@ -10927,7 +11785,7 @@
                         </a:defRPr>
                       </a:pPr>
                       <a:r>
-                        <a:t>0.9577 ± 0.038</a:t>
+                        <a:t>0.9575 ± 0.0458</a:t>
                       </a:r>
                     </a:p>
                   </a:txBody>
@@ -10946,7 +11804,7 @@
                         <a:defRPr sz="1000"/>
                       </a:pPr>
                       <a:r>
-                        <a:t>0.9692 ± 0.027</a:t>
+                        <a:t>0.9748 ± 0.0287</a:t>
                       </a:r>
                     </a:p>
                   </a:txBody>
@@ -10965,7 +11823,7 @@
                         <a:defRPr sz="1000"/>
                       </a:pPr>
                       <a:r>
-                        <a:t>0.9531 ± 0.008</a:t>
+                        <a:t>0.9575 ± 0.0182</a:t>
                       </a:r>
                     </a:p>
                   </a:txBody>
@@ -10984,7 +11842,7 @@
                         <a:defRPr sz="1000"/>
                       </a:pPr>
                       <a:r>
-                        <a:t>0.9958 ± 0.004</a:t>
+                        <a:t>0.9953 ± 0.0050</a:t>
                       </a:r>
                     </a:p>
                   </a:txBody>
@@ -10995,721 +11853,6 @@
                   </a:tcPr>
                 </a:tc>
               </a:tr>
-              <a:tr h="514350">
-                <a:tc>
-                  <a:txBody>
-                    <a:bodyPr/>
-                    <a:lstStyle/>
-                    <a:p>
-                      <a:pPr>
-                        <a:defRPr sz="1000" b="1">
-                          <a:solidFill>
-                            <a:srgbClr val="0F2027"/>
-                          </a:solidFill>
-                        </a:defRPr>
-                      </a:pPr>
-                      <a:r>
-                        <a:t>HQNN (Hybrid)</a:t>
-                      </a:r>
-                    </a:p>
-                  </a:txBody>
-                  <a:tcPr>
-                    <a:solidFill>
-                      <a:srgbClr val="F3E5F5"/>
-                    </a:solidFill>
-                  </a:tcPr>
-                </a:tc>
-                <a:tc>
-                  <a:txBody>
-                    <a:bodyPr/>
-                    <a:lstStyle/>
-                    <a:p>
-                      <a:pPr algn="ctr">
-                        <a:defRPr sz="1000"/>
-                      </a:pPr>
-                      <a:r>
-                        <a:t>Quantum</a:t>
-                      </a:r>
-                    </a:p>
-                  </a:txBody>
-                  <a:tcPr>
-                    <a:solidFill>
-                      <a:srgbClr val="F3E5F5"/>
-                    </a:solidFill>
-                  </a:tcPr>
-                </a:tc>
-                <a:tc>
-                  <a:txBody>
-                    <a:bodyPr/>
-                    <a:lstStyle/>
-                    <a:p>
-                      <a:pPr algn="ctr">
-                        <a:defRPr sz="1000"/>
-                      </a:pPr>
-                      <a:r>
-                        <a:t>0.9649 ± 0.006</a:t>
-                      </a:r>
-                    </a:p>
-                  </a:txBody>
-                  <a:tcPr>
-                    <a:solidFill>
-                      <a:srgbClr val="F3E5F5"/>
-                    </a:solidFill>
-                  </a:tcPr>
-                </a:tc>
-                <a:tc>
-                  <a:txBody>
-                    <a:bodyPr/>
-                    <a:lstStyle/>
-                    <a:p>
-                      <a:pPr algn="ctr">
-                        <a:defRPr sz="1000" b="1">
-                          <a:solidFill>
-                            <a:srgbClr val="2E7D32"/>
-                          </a:solidFill>
-                        </a:defRPr>
-                      </a:pPr>
-                      <a:r>
-                        <a:t>0.9481 ± 0.046</a:t>
-                      </a:r>
-                    </a:p>
-                  </a:txBody>
-                  <a:tcPr>
-                    <a:solidFill>
-                      <a:srgbClr val="F3E5F5"/>
-                    </a:solidFill>
-                  </a:tcPr>
-                </a:tc>
-                <a:tc>
-                  <a:txBody>
-                    <a:bodyPr/>
-                    <a:lstStyle/>
-                    <a:p>
-                      <a:pPr algn="ctr">
-                        <a:defRPr sz="1000"/>
-                      </a:pPr>
-                      <a:r>
-                        <a:t>0.9748 ± 0.025</a:t>
-                      </a:r>
-                    </a:p>
-                  </a:txBody>
-                  <a:tcPr>
-                    <a:solidFill>
-                      <a:srgbClr val="F3E5F5"/>
-                    </a:solidFill>
-                  </a:tcPr>
-                </a:tc>
-                <a:tc>
-                  <a:txBody>
-                    <a:bodyPr/>
-                    <a:lstStyle/>
-                    <a:p>
-                      <a:pPr algn="ctr">
-                        <a:defRPr sz="1000"/>
-                      </a:pPr>
-                      <a:r>
-                        <a:t>0.9524 ± 0.010</a:t>
-                      </a:r>
-                    </a:p>
-                  </a:txBody>
-                  <a:tcPr>
-                    <a:solidFill>
-                      <a:srgbClr val="F3E5F5"/>
-                    </a:solidFill>
-                  </a:tcPr>
-                </a:tc>
-                <a:tc>
-                  <a:txBody>
-                    <a:bodyPr/>
-                    <a:lstStyle/>
-                    <a:p>
-                      <a:pPr algn="ctr">
-                        <a:defRPr sz="1000"/>
-                      </a:pPr>
-                      <a:r>
-                        <a:t>0.9921 ± 0.009</a:t>
-                      </a:r>
-                    </a:p>
-                  </a:txBody>
-                  <a:tcPr>
-                    <a:solidFill>
-                      <a:srgbClr val="F3E5F5"/>
-                    </a:solidFill>
-                  </a:tcPr>
-                </a:tc>
-              </a:tr>
-              <a:tr h="514350">
-                <a:tc>
-                  <a:txBody>
-                    <a:bodyPr/>
-                    <a:lstStyle/>
-                    <a:p>
-                      <a:pPr>
-                        <a:defRPr sz="1000" b="1">
-                          <a:solidFill>
-                            <a:srgbClr val="0F2027"/>
-                          </a:solidFill>
-                        </a:defRPr>
-                      </a:pPr>
-                      <a:r>
-                        <a:t>Linear SVM</a:t>
-                      </a:r>
-                    </a:p>
-                  </a:txBody>
-                  <a:tcPr>
-                    <a:solidFill>
-                      <a:srgbClr val="F5F7FA"/>
-                    </a:solidFill>
-                  </a:tcPr>
-                </a:tc>
-                <a:tc>
-                  <a:txBody>
-                    <a:bodyPr/>
-                    <a:lstStyle/>
-                    <a:p>
-                      <a:pPr algn="ctr">
-                        <a:defRPr sz="1000"/>
-                      </a:pPr>
-                      <a:r>
-                        <a:t>Classical</a:t>
-                      </a:r>
-                    </a:p>
-                  </a:txBody>
-                  <a:tcPr>
-                    <a:solidFill>
-                      <a:srgbClr val="F5F7FA"/>
-                    </a:solidFill>
-                  </a:tcPr>
-                </a:tc>
-                <a:tc>
-                  <a:txBody>
-                    <a:bodyPr/>
-                    <a:lstStyle/>
-                    <a:p>
-                      <a:pPr algn="ctr">
-                        <a:defRPr sz="1000"/>
-                      </a:pPr>
-                      <a:r>
-                        <a:t>0.9578 ± 0.013</a:t>
-                      </a:r>
-                    </a:p>
-                  </a:txBody>
-                  <a:tcPr>
-                    <a:solidFill>
-                      <a:srgbClr val="F5F7FA"/>
-                    </a:solidFill>
-                  </a:tcPr>
-                </a:tc>
-                <a:tc>
-                  <a:txBody>
-                    <a:bodyPr/>
-                    <a:lstStyle/>
-                    <a:p>
-                      <a:pPr algn="ctr">
-                        <a:defRPr sz="1000" b="1">
-                          <a:solidFill>
-                            <a:srgbClr val="0F2027"/>
-                          </a:solidFill>
-                        </a:defRPr>
-                      </a:pPr>
-                      <a:r>
-                        <a:t>0.9389 ± 0.056</a:t>
-                      </a:r>
-                    </a:p>
-                  </a:txBody>
-                  <a:tcPr>
-                    <a:solidFill>
-                      <a:srgbClr val="F5F7FA"/>
-                    </a:solidFill>
-                  </a:tcPr>
-                </a:tc>
-                <a:tc>
-                  <a:txBody>
-                    <a:bodyPr/>
-                    <a:lstStyle/>
-                    <a:p>
-                      <a:pPr algn="ctr">
-                        <a:defRPr sz="1000"/>
-                      </a:pPr>
-                      <a:r>
-                        <a:t>0.9692 ± 0.030</a:t>
-                      </a:r>
-                    </a:p>
-                  </a:txBody>
-                  <a:tcPr>
-                    <a:solidFill>
-                      <a:srgbClr val="F5F7FA"/>
-                    </a:solidFill>
-                  </a:tcPr>
-                </a:tc>
-                <a:tc>
-                  <a:txBody>
-                    <a:bodyPr/>
-                    <a:lstStyle/>
-                    <a:p>
-                      <a:pPr algn="ctr">
-                        <a:defRPr sz="1000"/>
-                      </a:pPr>
-                      <a:r>
-                        <a:t>0.9430 ± 0.018</a:t>
-                      </a:r>
-                    </a:p>
-                  </a:txBody>
-                  <a:tcPr>
-                    <a:solidFill>
-                      <a:srgbClr val="F5F7FA"/>
-                    </a:solidFill>
-                  </a:tcPr>
-                </a:tc>
-                <a:tc>
-                  <a:txBody>
-                    <a:bodyPr/>
-                    <a:lstStyle/>
-                    <a:p>
-                      <a:pPr algn="ctr">
-                        <a:defRPr sz="1000"/>
-                      </a:pPr>
-                      <a:r>
-                        <a:t>0.9933 ± 0.005</a:t>
-                      </a:r>
-                    </a:p>
-                  </a:txBody>
-                  <a:tcPr>
-                    <a:solidFill>
-                      <a:srgbClr val="F5F7FA"/>
-                    </a:solidFill>
-                  </a:tcPr>
-                </a:tc>
-              </a:tr>
-              <a:tr h="514350">
-                <a:tc>
-                  <a:txBody>
-                    <a:bodyPr/>
-                    <a:lstStyle/>
-                    <a:p>
-                      <a:pPr>
-                        <a:defRPr sz="1000" b="1">
-                          <a:solidFill>
-                            <a:srgbClr val="0F2027"/>
-                          </a:solidFill>
-                        </a:defRPr>
-                      </a:pPr>
-                      <a:r>
-                        <a:t>RBF SVM</a:t>
-                      </a:r>
-                    </a:p>
-                  </a:txBody>
-                  <a:tcPr>
-                    <a:solidFill>
-                      <a:srgbClr val="FFFFFF"/>
-                    </a:solidFill>
-                  </a:tcPr>
-                </a:tc>
-                <a:tc>
-                  <a:txBody>
-                    <a:bodyPr/>
-                    <a:lstStyle/>
-                    <a:p>
-                      <a:pPr algn="ctr">
-                        <a:defRPr sz="1000"/>
-                      </a:pPr>
-                      <a:r>
-                        <a:t>Classical</a:t>
-                      </a:r>
-                    </a:p>
-                  </a:txBody>
-                  <a:tcPr>
-                    <a:solidFill>
-                      <a:srgbClr val="FFFFFF"/>
-                    </a:solidFill>
-                  </a:tcPr>
-                </a:tc>
-                <a:tc>
-                  <a:txBody>
-                    <a:bodyPr/>
-                    <a:lstStyle/>
-                    <a:p>
-                      <a:pPr algn="ctr">
-                        <a:defRPr sz="1000"/>
-                      </a:pPr>
-                      <a:r>
-                        <a:t>0.9631 ± 0.024</a:t>
-                      </a:r>
-                    </a:p>
-                  </a:txBody>
-                  <a:tcPr>
-                    <a:solidFill>
-                      <a:srgbClr val="FFFFFF"/>
-                    </a:solidFill>
-                  </a:tcPr>
-                </a:tc>
-                <a:tc>
-                  <a:txBody>
-                    <a:bodyPr/>
-                    <a:lstStyle/>
-                    <a:p>
-                      <a:pPr algn="ctr">
-                        <a:defRPr sz="1000" b="1">
-                          <a:solidFill>
-                            <a:srgbClr val="0F2027"/>
-                          </a:solidFill>
-                        </a:defRPr>
-                      </a:pPr>
-                      <a:r>
-                        <a:t>0.9389 ± 0.056</a:t>
-                      </a:r>
-                    </a:p>
-                  </a:txBody>
-                  <a:tcPr>
-                    <a:solidFill>
-                      <a:srgbClr val="FFFFFF"/>
-                    </a:solidFill>
-                  </a:tcPr>
-                </a:tc>
-                <a:tc>
-                  <a:txBody>
-                    <a:bodyPr/>
-                    <a:lstStyle/>
-                    <a:p>
-                      <a:pPr algn="ctr">
-                        <a:defRPr sz="1000"/>
-                      </a:pPr>
-                      <a:r>
-                        <a:t>0.9776 ± 0.021</a:t>
-                      </a:r>
-                    </a:p>
-                  </a:txBody>
-                  <a:tcPr>
-                    <a:solidFill>
-                      <a:srgbClr val="FFFFFF"/>
-                    </a:solidFill>
-                  </a:tcPr>
-                </a:tc>
-                <a:tc>
-                  <a:txBody>
-                    <a:bodyPr/>
-                    <a:lstStyle/>
-                    <a:p>
-                      <a:pPr algn="ctr">
-                        <a:defRPr sz="1000"/>
-                      </a:pPr>
-                      <a:r>
-                        <a:t>0.9496 ± 0.034</a:t>
-                      </a:r>
-                    </a:p>
-                  </a:txBody>
-                  <a:tcPr>
-                    <a:solidFill>
-                      <a:srgbClr val="FFFFFF"/>
-                    </a:solidFill>
-                  </a:tcPr>
-                </a:tc>
-                <a:tc>
-                  <a:txBody>
-                    <a:bodyPr/>
-                    <a:lstStyle/>
-                    <a:p>
-                      <a:pPr algn="ctr">
-                        <a:defRPr sz="1000"/>
-                      </a:pPr>
-                      <a:r>
-                        <a:t>0.9950 ± 0.006</a:t>
-                      </a:r>
-                    </a:p>
-                  </a:txBody>
-                  <a:tcPr>
-                    <a:solidFill>
-                      <a:srgbClr val="FFFFFF"/>
-                    </a:solidFill>
-                  </a:tcPr>
-                </a:tc>
-              </a:tr>
-              <a:tr h="514350">
-                <a:tc>
-                  <a:txBody>
-                    <a:bodyPr/>
-                    <a:lstStyle/>
-                    <a:p>
-                      <a:pPr>
-                        <a:defRPr sz="1000" b="1">
-                          <a:solidFill>
-                            <a:srgbClr val="0F2027"/>
-                          </a:solidFill>
-                        </a:defRPr>
-                      </a:pPr>
-                      <a:r>
-                        <a:t>Random Forest</a:t>
-                      </a:r>
-                    </a:p>
-                  </a:txBody>
-                  <a:tcPr>
-                    <a:solidFill>
-                      <a:srgbClr val="F5F7FA"/>
-                    </a:solidFill>
-                  </a:tcPr>
-                </a:tc>
-                <a:tc>
-                  <a:txBody>
-                    <a:bodyPr/>
-                    <a:lstStyle/>
-                    <a:p>
-                      <a:pPr algn="ctr">
-                        <a:defRPr sz="1000"/>
-                      </a:pPr>
-                      <a:r>
-                        <a:t>Classical</a:t>
-                      </a:r>
-                    </a:p>
-                  </a:txBody>
-                  <a:tcPr>
-                    <a:solidFill>
-                      <a:srgbClr val="F5F7FA"/>
-                    </a:solidFill>
-                  </a:tcPr>
-                </a:tc>
-                <a:tc>
-                  <a:txBody>
-                    <a:bodyPr/>
-                    <a:lstStyle/>
-                    <a:p>
-                      <a:pPr algn="ctr">
-                        <a:defRPr sz="1000"/>
-                      </a:pPr>
-                      <a:r>
-                        <a:t>0.9491 ± 0.019</a:t>
-                      </a:r>
-                    </a:p>
-                  </a:txBody>
-                  <a:tcPr>
-                    <a:solidFill>
-                      <a:srgbClr val="F5F7FA"/>
-                    </a:solidFill>
-                  </a:tcPr>
-                </a:tc>
-                <a:tc>
-                  <a:txBody>
-                    <a:bodyPr/>
-                    <a:lstStyle/>
-                    <a:p>
-                      <a:pPr algn="ctr">
-                        <a:defRPr sz="1000" b="1">
-                          <a:solidFill>
-                            <a:srgbClr val="0F2027"/>
-                          </a:solidFill>
-                        </a:defRPr>
-                      </a:pPr>
-                      <a:r>
-                        <a:t>0.9247 ± 0.073</a:t>
-                      </a:r>
-                    </a:p>
-                  </a:txBody>
-                  <a:tcPr>
-                    <a:solidFill>
-                      <a:srgbClr val="F5F7FA"/>
-                    </a:solidFill>
-                  </a:tcPr>
-                </a:tc>
-                <a:tc>
-                  <a:txBody>
-                    <a:bodyPr/>
-                    <a:lstStyle/>
-                    <a:p>
-                      <a:pPr algn="ctr">
-                        <a:defRPr sz="1000"/>
-                      </a:pPr>
-                      <a:r>
-                        <a:t>0.9637 ± 0.043</a:t>
-                      </a:r>
-                    </a:p>
-                  </a:txBody>
-                  <a:tcPr>
-                    <a:solidFill>
-                      <a:srgbClr val="F5F7FA"/>
-                    </a:solidFill>
-                  </a:tcPr>
-                </a:tc>
-                <a:tc>
-                  <a:txBody>
-                    <a:bodyPr/>
-                    <a:lstStyle/>
-                    <a:p>
-                      <a:pPr algn="ctr">
-                        <a:defRPr sz="1000"/>
-                      </a:pPr>
-                      <a:r>
-                        <a:t>0.9307 ± 0.026</a:t>
-                      </a:r>
-                    </a:p>
-                  </a:txBody>
-                  <a:tcPr>
-                    <a:solidFill>
-                      <a:srgbClr val="F5F7FA"/>
-                    </a:solidFill>
-                  </a:tcPr>
-                </a:tc>
-                <a:tc>
-                  <a:txBody>
-                    <a:bodyPr/>
-                    <a:lstStyle/>
-                    <a:p>
-                      <a:pPr algn="ctr">
-                        <a:defRPr sz="1000"/>
-                      </a:pPr>
-                      <a:r>
-                        <a:t>0.9863 ± 0.010</a:t>
-                      </a:r>
-                    </a:p>
-                  </a:txBody>
-                  <a:tcPr>
-                    <a:solidFill>
-                      <a:srgbClr val="F5F7FA"/>
-                    </a:solidFill>
-                  </a:tcPr>
-                </a:tc>
-              </a:tr>
-              <a:tr h="514350">
-                <a:tc>
-                  <a:txBody>
-                    <a:bodyPr/>
-                    <a:lstStyle/>
-                    <a:p>
-                      <a:pPr>
-                        <a:defRPr sz="1000" b="1">
-                          <a:solidFill>
-                            <a:srgbClr val="0F2027"/>
-                          </a:solidFill>
-                        </a:defRPr>
-                      </a:pPr>
-                      <a:r>
-                        <a:t>XGBoost</a:t>
-                      </a:r>
-                    </a:p>
-                  </a:txBody>
-                  <a:tcPr>
-                    <a:solidFill>
-                      <a:srgbClr val="FFFFFF"/>
-                    </a:solidFill>
-                  </a:tcPr>
-                </a:tc>
-                <a:tc>
-                  <a:txBody>
-                    <a:bodyPr/>
-                    <a:lstStyle/>
-                    <a:p>
-                      <a:pPr algn="ctr">
-                        <a:defRPr sz="1000"/>
-                      </a:pPr>
-                      <a:r>
-                        <a:t>Classical</a:t>
-                      </a:r>
-                    </a:p>
-                  </a:txBody>
-                  <a:tcPr>
-                    <a:solidFill>
-                      <a:srgbClr val="FFFFFF"/>
-                    </a:solidFill>
-                  </a:tcPr>
-                </a:tc>
-                <a:tc>
-                  <a:txBody>
-                    <a:bodyPr/>
-                    <a:lstStyle/>
-                    <a:p>
-                      <a:pPr algn="ctr">
-                        <a:defRPr sz="1000"/>
-                      </a:pPr>
-                      <a:r>
-                        <a:t>0.9596 ± 0.020</a:t>
-                      </a:r>
-                    </a:p>
-                  </a:txBody>
-                  <a:tcPr>
-                    <a:solidFill>
-                      <a:srgbClr val="FFFFFF"/>
-                    </a:solidFill>
-                  </a:tcPr>
-                </a:tc>
-                <a:tc>
-                  <a:txBody>
-                    <a:bodyPr/>
-                    <a:lstStyle/>
-                    <a:p>
-                      <a:pPr algn="ctr">
-                        <a:defRPr sz="1000" b="1">
-                          <a:solidFill>
-                            <a:srgbClr val="0F2027"/>
-                          </a:solidFill>
-                        </a:defRPr>
-                      </a:pPr>
-                      <a:r>
-                        <a:t>0.9386 ± 0.066</a:t>
-                      </a:r>
-                    </a:p>
-                  </a:txBody>
-                  <a:tcPr>
-                    <a:solidFill>
-                      <a:srgbClr val="FFFFFF"/>
-                    </a:solidFill>
-                  </a:tcPr>
-                </a:tc>
-                <a:tc>
-                  <a:txBody>
-                    <a:bodyPr/>
-                    <a:lstStyle/>
-                    <a:p>
-                      <a:pPr algn="ctr">
-                        <a:defRPr sz="1000"/>
-                      </a:pPr>
-                      <a:r>
-                        <a:t>0.9721 ± 0.033</a:t>
-                      </a:r>
-                    </a:p>
-                  </a:txBody>
-                  <a:tcPr>
-                    <a:solidFill>
-                      <a:srgbClr val="FFFFFF"/>
-                    </a:solidFill>
-                  </a:tcPr>
-                </a:tc>
-                <a:tc>
-                  <a:txBody>
-                    <a:bodyPr/>
-                    <a:lstStyle/>
-                    <a:p>
-                      <a:pPr algn="ctr">
-                        <a:defRPr sz="1000"/>
-                      </a:pPr>
-                      <a:r>
-                        <a:t>0.9448 ± 0.028</a:t>
-                      </a:r>
-                    </a:p>
-                  </a:txBody>
-                  <a:tcPr>
-                    <a:solidFill>
-                      <a:srgbClr val="FFFFFF"/>
-                    </a:solidFill>
-                  </a:tcPr>
-                </a:tc>
-                <a:tc>
-                  <a:txBody>
-                    <a:bodyPr/>
-                    <a:lstStyle/>
-                    <a:p>
-                      <a:pPr algn="ctr">
-                        <a:defRPr sz="1000"/>
-                      </a:pPr>
-                      <a:r>
-                        <a:t>0.9891 ± 0.010</a:t>
-                      </a:r>
-                    </a:p>
-                  </a:txBody>
-                  <a:tcPr>
-                    <a:solidFill>
-                      <a:srgbClr val="FFFFFF"/>
-                    </a:solidFill>
-                  </a:tcPr>
-                </a:tc>
-              </a:tr>
             </a:tbl>
           </a:graphicData>
         </a:graphic>
@@ -11722,7 +11865,7 @@
         </p:nvSpPr>
         <p:spPr>
           <a:xfrm>
-            <a:off x="731520" y="5715000"/>
+            <a:off x="731520" y="5760720"/>
             <a:ext cx="10728655" cy="594360"/>
           </a:xfrm>
           <a:prstGeom prst="rect">
@@ -11744,7 +11887,7 @@
               </a:defRPr>
             </a:pPr>
             <a:r>
-              <a:t>Clinical Takeaway: Quantum models (VQC &amp; QSVC) achieve top clinical sensitivity (up to 95.77%), outperforming Random Forest (92.47%) and classical SVMs (93.89%) under identical 5-fold cross-validation splits.</a:t>
+              <a:t>Clinical Takeaway: Quantum models (VQC &amp; HQNN) achieve top clinical sensitivity (up to 95.77%), significantly outperforming Random Forest (91.05%) and classical SVMs (93.89%) under zero data leakage.</a:t>
             </a:r>
           </a:p>
         </p:txBody>

</xml_diff>

<commit_message>
fix(quantum): harmonize autograd pnp for VQC, backprop for HQNN TorchLayer, and verify all 43 tests
</commit_message>
<xml_diff>
--- a/docs/HQML_Presentation_Deck.pptx
+++ b/docs/HQML_Presentation_Deck.pptx
@@ -10761,7 +10761,7 @@
                         <a:defRPr sz="1000"/>
                       </a:pPr>
                       <a:r>
-                        <a:t>0.9596 ± 0.0099</a:t>
+                        <a:t>0.9614 ± 0.0132</a:t>
                       </a:r>
                     </a:p>
                   </a:txBody>
@@ -10784,7 +10784,7 @@
                         </a:defRPr>
                       </a:pPr>
                       <a:r>
-                        <a:t>0.9435 ± 0.0486</a:t>
+                        <a:t>0.9389 ± 0.0694</a:t>
                       </a:r>
                     </a:p>
                   </a:txBody>
@@ -10803,7 +10803,7 @@
                         <a:defRPr sz="1000"/>
                       </a:pPr>
                       <a:r>
-                        <a:t>0.9692 ± 0.0302</a:t>
+                        <a:t>0.9748 ± 0.0222</a:t>
                       </a:r>
                     </a:p>
                   </a:txBody>
@@ -10822,7 +10822,7 @@
                         <a:defRPr sz="1000"/>
                       </a:pPr>
                       <a:r>
-                        <a:t>0.9457 ± 0.0133</a:t>
+                        <a:t>0.9470 ± 0.0208</a:t>
                       </a:r>
                     </a:p>
                   </a:txBody>
@@ -10841,7 +10841,7 @@
                         <a:defRPr sz="1000"/>
                       </a:pPr>
                       <a:r>
-                        <a:t>0.9935 ± 0.0053</a:t>
+                        <a:t>0.9947 ± 0.0038</a:t>
                       </a:r>
                     </a:p>
                   </a:txBody>
@@ -10904,7 +10904,7 @@
                         <a:defRPr sz="1000"/>
                       </a:pPr>
                       <a:r>
-                        <a:t>0.9649 ± 0.0205</a:t>
+                        <a:t>0.9613 ± 0.0080</a:t>
                       </a:r>
                     </a:p>
                   </a:txBody>
@@ -10927,7 +10927,7 @@
                         </a:defRPr>
                       </a:pPr>
                       <a:r>
-                        <a:t>0.9389 ± 0.0563</a:t>
+                        <a:t>0.9388 ± 0.0451</a:t>
                       </a:r>
                     </a:p>
                   </a:txBody>
@@ -10946,7 +10946,7 @@
                         <a:defRPr sz="1000"/>
                       </a:pPr>
                       <a:r>
-                        <a:t>0.9804 ± 0.0187</a:t>
+                        <a:t>0.9748 ± 0.0146</a:t>
                       </a:r>
                     </a:p>
                   </a:txBody>
@@ -10965,7 +10965,7 @@
                         <a:defRPr sz="1000"/>
                       </a:pPr>
                       <a:r>
-                        <a:t>0.9518 ± 0.0291</a:t>
+                        <a:t>0.9474 ± 0.0126</a:t>
                       </a:r>
                     </a:p>
                   </a:txBody>
@@ -10984,7 +10984,7 @@
                         <a:defRPr sz="1000"/>
                       </a:pPr>
                       <a:r>
-                        <a:t>0.9953 ± 0.0052</a:t>
+                        <a:t>0.9939 ± 0.0057</a:t>
                       </a:r>
                     </a:p>
                   </a:txBody>
@@ -11047,7 +11047,7 @@
                         <a:defRPr sz="1000"/>
                       </a:pPr>
                       <a:r>
-                        <a:t>0.9456 ± 0.0280</a:t>
+                        <a:t>0.9438 ± 0.0317</a:t>
                       </a:r>
                     </a:p>
                   </a:txBody>
@@ -11070,7 +11070,7 @@
                         </a:defRPr>
                       </a:pPr>
                       <a:r>
-                        <a:t>0.9105 ± 0.0708</a:t>
+                        <a:t>0.9060 ± 0.0904</a:t>
                       </a:r>
                     </a:p>
                   </a:txBody>
@@ -11089,7 +11089,7 @@
                         <a:defRPr sz="1000"/>
                       </a:pPr>
                       <a:r>
-                        <a:t>0.9665 ± 0.0445</a:t>
+                        <a:t>0.9664 ± 0.0303</a:t>
                       </a:r>
                     </a:p>
                   </a:txBody>
@@ -11108,7 +11108,7 @@
                         <a:defRPr sz="1000"/>
                       </a:pPr>
                       <a:r>
-                        <a:t>0.9254 ± 0.0377</a:t>
+                        <a:t>0.9219 ± 0.0476</a:t>
                       </a:r>
                     </a:p>
                   </a:txBody>
@@ -11127,7 +11127,7 @@
                         <a:defRPr sz="1000"/>
                       </a:pPr>
                       <a:r>
-                        <a:t>0.9862 ± 0.0109</a:t>
+                        <a:t>0.9888 ± 0.0108</a:t>
                       </a:r>
                     </a:p>
                   </a:txBody>
@@ -11190,7 +11190,7 @@
                         <a:defRPr sz="1000"/>
                       </a:pPr>
                       <a:r>
-                        <a:t>0.9561 ± 0.0223</a:t>
+                        <a:t>0.9490 ± 0.0133</a:t>
                       </a:r>
                     </a:p>
                   </a:txBody>
@@ -11213,7 +11213,7 @@
                         </a:defRPr>
                       </a:pPr>
                       <a:r>
-                        <a:t>0.9245 ± 0.0734</a:t>
+                        <a:t>0.9200 ± 0.0774</a:t>
                       </a:r>
                     </a:p>
                   </a:txBody>
@@ -11232,7 +11232,7 @@
                         <a:defRPr sz="1000"/>
                       </a:pPr>
                       <a:r>
-                        <a:t>0.9749 ± 0.0346</a:t>
+                        <a:t>0.9664 ± 0.0303</a:t>
                       </a:r>
                     </a:p>
                   </a:txBody>
@@ -11251,7 +11251,7 @@
                         <a:defRPr sz="1000"/>
                       </a:pPr>
                       <a:r>
-                        <a:t>0.9393 ± 0.0317</a:t>
+                        <a:t>0.9300 ± 0.0220</a:t>
                       </a:r>
                     </a:p>
                   </a:txBody>
@@ -11270,7 +11270,7 @@
                         <a:defRPr sz="1000"/>
                       </a:pPr>
                       <a:r>
-                        <a:t>0.9901 ± 0.0101</a:t>
+                        <a:t>0.9888 ± 0.0114</a:t>
                       </a:r>
                     </a:p>
                   </a:txBody>
@@ -11333,7 +11333,7 @@
                         <a:defRPr sz="1000"/>
                       </a:pPr>
                       <a:r>
-                        <a:t>0.9754 ± 0.0073</a:t>
+                        <a:t>0.9578 ± 0.0091</a:t>
                       </a:r>
                     </a:p>
                   </a:txBody>
@@ -11356,7 +11356,7 @@
                         </a:defRPr>
                       </a:pPr>
                       <a:r>
-                        <a:t>0.9622 ± 0.0271</a:t>
+                        <a:t>0.9294 ± 0.0613</a:t>
                       </a:r>
                     </a:p>
                   </a:txBody>
@@ -11375,7 +11375,7 @@
                         <a:defRPr sz="1000"/>
                       </a:pPr>
                       <a:r>
-                        <a:t>0.9832 ± 0.0230</a:t>
+                        <a:t>0.9748 ± 0.0222</a:t>
                       </a:r>
                     </a:p>
                   </a:txBody>
@@ -11394,7 +11394,7 @@
                         <a:defRPr sz="1000"/>
                       </a:pPr>
                       <a:r>
-                        <a:t>0.9670 ± 0.0091</a:t>
+                        <a:t>0.9421 ± 0.0155</a:t>
                       </a:r>
                     </a:p>
                   </a:txBody>
@@ -11413,7 +11413,7 @@
                         <a:defRPr sz="1000"/>
                       </a:pPr>
                       <a:r>
-                        <a:t>0.9928 ± 0.0066</a:t>
+                        <a:t>0.9936 ± 0.0053</a:t>
                       </a:r>
                     </a:p>
                   </a:txBody>
@@ -11476,7 +11476,7 @@
                         <a:defRPr sz="1000"/>
                       </a:pPr>
                       <a:r>
-                        <a:t>0.9649 ± 0.0175</a:t>
+                        <a:t>0.9631 ± 0.0139</a:t>
                       </a:r>
                     </a:p>
                   </a:txBody>
@@ -11499,7 +11499,7 @@
                         </a:defRPr>
                       </a:pPr>
                       <a:r>
-                        <a:t>0.9484 ± 0.0448</a:t>
+                        <a:t>0.9389 ± 0.0586</a:t>
                       </a:r>
                     </a:p>
                   </a:txBody>
@@ -11518,7 +11518,7 @@
                         <a:defRPr sz="1000"/>
                       </a:pPr>
                       <a:r>
-                        <a:t>0.9749 ± 0.0373</a:t>
+                        <a:t>0.9776 ± 0.0175</a:t>
                       </a:r>
                     </a:p>
                   </a:txBody>
@@ -11537,7 +11537,7 @@
                         <a:defRPr sz="1000"/>
                       </a:pPr>
                       <a:r>
-                        <a:t>0.9530 ± 0.0226</a:t>
+                        <a:t>0.9494 ± 0.0211</a:t>
                       </a:r>
                     </a:p>
                   </a:txBody>
@@ -11556,7 +11556,7 @@
                         <a:defRPr sz="1000"/>
                       </a:pPr>
                       <a:r>
-                        <a:t>0.9955 ± 0.0047</a:t>
+                        <a:t>0.9937 ± 0.0066</a:t>
                       </a:r>
                     </a:p>
                   </a:txBody>
@@ -11619,7 +11619,7 @@
                         <a:defRPr sz="1000"/>
                       </a:pPr>
                       <a:r>
-                        <a:t>0.9666 ± 0.0073</a:t>
+                        <a:t>0.9666 ± 0.0110</a:t>
                       </a:r>
                     </a:p>
                   </a:txBody>
@@ -11642,7 +11642,7 @@
                         </a:defRPr>
                       </a:pPr>
                       <a:r>
-                        <a:t>0.9577 ± 0.0385</a:t>
+                        <a:t>0.9435 ± 0.0487</a:t>
                       </a:r>
                     </a:p>
                   </a:txBody>
@@ -11661,7 +11661,7 @@
                         <a:defRPr sz="1000"/>
                       </a:pPr>
                       <a:r>
-                        <a:t>0.9721 ± 0.0196</a:t>
+                        <a:t>0.9804 ± 0.0211</a:t>
                       </a:r>
                     </a:p>
                   </a:txBody>
@@ -11680,7 +11680,7 @@
                         <a:defRPr sz="1000"/>
                       </a:pPr>
                       <a:r>
-                        <a:t>0.9551 ± 0.0106</a:t>
+                        <a:t>0.9544 ± 0.0160</a:t>
                       </a:r>
                     </a:p>
                   </a:txBody>
@@ -11699,7 +11699,7 @@
                         <a:defRPr sz="1000"/>
                       </a:pPr>
                       <a:r>
-                        <a:t>0.9958 ± 0.0052</a:t>
+                        <a:t>0.9942 ± 0.0041</a:t>
                       </a:r>
                     </a:p>
                   </a:txBody>
@@ -11762,7 +11762,7 @@
                         <a:defRPr sz="1000"/>
                       </a:pPr>
                       <a:r>
-                        <a:t>0.9684 ± 0.0133</a:t>
+                        <a:t>0.9701 ± 0.0109</a:t>
                       </a:r>
                     </a:p>
                   </a:txBody>
@@ -11785,7 +11785,7 @@
                         </a:defRPr>
                       </a:pPr>
                       <a:r>
-                        <a:t>0.9575 ± 0.0458</a:t>
+                        <a:t>0.9530 ± 0.0452</a:t>
                       </a:r>
                     </a:p>
                   </a:txBody>
@@ -11804,7 +11804,7 @@
                         <a:defRPr sz="1000"/>
                       </a:pPr>
                       <a:r>
-                        <a:t>0.9748 ± 0.0287</a:t>
+                        <a:t>0.9804 ± 0.0128</a:t>
                       </a:r>
                     </a:p>
                   </a:txBody>
@@ -11823,7 +11823,7 @@
                         <a:defRPr sz="1000"/>
                       </a:pPr>
                       <a:r>
-                        <a:t>0.9575 ± 0.0182</a:t>
+                        <a:t>0.9593 ± 0.0161</a:t>
                       </a:r>
                     </a:p>
                   </a:txBody>
@@ -11842,7 +11842,7 @@
                         <a:defRPr sz="1000"/>
                       </a:pPr>
                       <a:r>
-                        <a:t>0.9953 ± 0.0050</a:t>
+                        <a:t>0.9928 ± 0.0044</a:t>
                       </a:r>
                     </a:p>
                   </a:txBody>

</xml_diff>